<commit_message>
[sj] docs: 접근법 유형화 (md + ppt) + V75~V79 결과
24_APPROACH_TYPOLOGY.md / .pptx — V1~V79 를 "무엇을 건드렸는가"로 9유형 분류
  1 Y를 바꾸면 (3/1)   2 피처를 더하면 (9/4)   3 피처를 빼면 (4/1)
  4 모델을 바꾸면 (5/1) 5 학습 방식 (5/3)      6 합치는 법 (6/1)
  7 사후 보정 (5/1)     8 쪼개면 (3/0)         9 측정을 의심하면
  각 유형마다 실험 설명 / 결과 / 결론. 채택 12/46.

V75 season 현행 유지 (2024 제거 -31.00, 순번 +0.38)
V70 attention 피처 기각 (B1 -46.16, B2 -76.56)
V77 fold 2023 base -140.20 은 전부 오프셋 (+0.0224 -> 손실 200.88)
V78 정직한 평균 이동 규칙 없음. 프로덕션 오프셋이 이미 +0.0002
V79 블렌드 오프셋 +0.002212 -> 2025 레벨 위험 약 2점. V61 우려 해소
    블렌드 이득 raw +39.95 vs 오프셋제거 +41.88 = 진짜 신호

harness.metrics() 에 offset / bss_centered 추가
21_TEAM_SUMMARY 원리 3 수정: "정확도가 비슷한 멤버들 사이에서는" 단서 추가

Co-Authored-By: Claude Opus 5 <noreply@anthropic.com>
</commit_message>
<xml_diff>
--- a/cowork/sj/claude/23_TEAM_DECK.pptx
+++ b/cowork/sj/claude/23_TEAM_DECK.pptx
@@ -5425,7 +5425,7 @@
                 <a:ea typeface="Calibri" pitchFamily="34" charset="-122"/>
                 <a:cs typeface="Calibri" pitchFamily="34" charset="-120"/>
               </a:rPr>
-              <a:t>멤버의 가치는 정확도가 아니라 비상관성</a:t>
+              <a:t>정확도가 비슷한 멤버들 사이에서는 비상관성이 결정한다</a:t>
             </a:r>
             <a:endParaRPr lang="en-US" sz="1450" dirty="0"/>
           </a:p>
@@ -5467,7 +5467,7 @@
                 <a:ea typeface="Calibri" pitchFamily="34" charset="-122"/>
                 <a:cs typeface="Calibri" pitchFamily="34" charset="-120"/>
               </a:rPr>
-              <a:t>같은 피처로 만든 직접 모델이 단독 751.20 으로 성분 분해(745.30)보다 좋은데, 결합은 +23.43 vs +41.04 로 밀렸다. 차이는 base 와의 상관뿐(0.8529 vs 0.8219).</a:t>
+              <a:t>직접 모델이 단독 751.20 으로 성분 분해(745.30)보다 나은데 결합은 +23.43 vs +41.04 로 밀렸다 — 차이는 상관뿐. 단 정확도가 무너지면 예외다: V70 은 상관 0.6032(역대 최저)를 얻고도 단독이 653 떨어져 −76.56.</a:t>
             </a:r>
             <a:endParaRPr lang="en-US" sz="1150" dirty="0"/>
           </a:p>
@@ -5506,7 +5506,7 @@
                 <a:ea typeface="Calibri" pitchFamily="34" charset="-122"/>
                 <a:cs typeface="Calibri" pitchFamily="34" charset="-120"/>
               </a:rPr>
-              <a:t>V65 · V66</a:t>
+              <a:t>V65 · V66 · V70</a:t>
             </a:r>
             <a:endParaRPr lang="en-US" sz="1100" dirty="0"/>
           </a:p>

</xml_diff>